<commit_message>
Deck: corrected novelty claims after prior-art check (closed-loop agent + control-ladder benchmark)
Co-Authored-By: Claude Opus 5 <noreply@anthropic.com>
</commit_message>
<xml_diff>
--- a/docs/EL_Phase1_Connectome_Lab.pptx
+++ b/docs/EL_Phase1_Connectome_Lab.pptx
@@ -15770,7 +15770,7 @@
             </a:pPr>
             <a:r>
               <a:rPr lang="en-IN" sz="1500"/>
-              <a:t>A benchmark table and shuffle curve showing where fly wiring beats, ties or loses to random and engineered networks.</a:t>
+              <a:t>A benchmark table showing, task by task, where fly wiring beats, ties or loses each control — and therefore which structural property matters. Early result: on Flappy Bird a brain beats no-brain 5–10× when memory is needed, but real wiring does not beat scrambled wiring.</a:t>
             </a:r>
             <a:endParaRPr sz="1500"/>
           </a:p>
@@ -16445,7 +16445,7 @@
             </a:r>
             <a:r>
               <a:rPr lang="en-IN" sz="1800"/>
-              <a:t>For the first time we have a complete brain wiring diagram, and it runs on a laptop — we have already reproduced a Nature 2024 result and animated it. Our project turns this into a platform: a simulator, a labelled atlas, a virtual fly, an AI agent that experiments on the brain by itself, and a fair test of whether evolution's wiring beats human-designed networks.</a:t>
+              <a:t>The complete fly brain wiring runs on a laptop — we reproduced a Nature 2024 result and built a piece of the brain into a Flappy Bird player. Our two new contributions: an AI agent that plans and runs its own experiments to discover circuits, and a controlled benchmark that tells us which features of evolved wiring matter for computation. The simulator, virtual fly and dashboard are the platform that makes both possible.</a:t>
             </a:r>
             <a:endParaRPr sz="1800"/>
           </a:p>
@@ -18986,11 +18986,38 @@
             </a:pPr>
             <a:r>
               <a:rPr lang="en-IN" sz="1500" b="1"/>
+              <a:t xml:space="preserve">Already exists: </a:t>
+            </a:r>
+            <a:r>
+              <a:rPr lang="en-IN" sz="1500"/>
+              <a:t>browser simulators (FlyBrain), natural-language command interfaces (lixiang1076/fly-brain, CHIMERA), single-task fly-vs-random comparisons (ESA 2025; train-your-fly).</a:t>
+            </a:r>
+            <a:endParaRPr sz="1500"/>
+          </a:p>
+          <a:p>
+            <a:pPr marL="228600" lvl="0" indent="-228600" algn="l" rtl="0">
+              <a:lnSpc>
+                <a:spcPct val="90000"/>
+              </a:lnSpc>
+              <a:spcBef>
+                <a:spcPts val="1000"/>
+              </a:spcBef>
+              <a:spcAft>
+                <a:spcPts val="0"/>
+              </a:spcAft>
+              <a:buClr>
+                <a:srgbClr val="002060"/>
+              </a:buClr>
+              <a:buSzPts val="2800"/>
+              <a:buChar char="•"/>
+            </a:pPr>
+            <a:r>
+              <a:rPr lang="en-IN" sz="1500" b="1"/>
               <a:t xml:space="preserve">Gap: </a:t>
             </a:r>
             <a:r>
               <a:rPr lang="en-IN" sz="1500"/>
-              <a:t>no systematic test of evolved vs random/engineered wiring across many tasks; no autonomous AI experimentation on a connectome.</a:t>
+              <a:t>no closed-loop AI agent that plans and interprets its own experiments on a connectome; no multi-task benchmark with a ladder of controls showing WHICH structural feature of evolved wiring matters.</a:t>
             </a:r>
             <a:endParaRPr sz="1500"/>
           </a:p>
@@ -19605,7 +19632,7 @@
             </a:r>
             <a:r>
               <a:rPr lang="en-IN" sz="1500"/>
-              <a:t>the wiring as a PyTorch model (frozen and trainable) vs random, small-world and MLP networks on 3–5 tasks, with a "how much fly is left" shuffle curve.</a:t>
+              <a:t>the wiring as a PyTorch model (frozen and trainable) vs a ladder of controls — fully scrambled, degree-preserving, sign-preserving, module-preserving — and standard networks, on 3–5 tasks (Flappy Bird is task #1, already running).</a:t>
             </a:r>
             <a:endParaRPr sz="1500"/>
           </a:p>
@@ -19655,11 +19682,11 @@
             </a:pPr>
             <a:r>
               <a:rPr lang="en-IN" sz="1600" b="1"/>
-              <a:t xml:space="preserve">Contribution: </a:t>
+              <a:t xml:space="preserve">Novel contribution: </a:t>
             </a:r>
             <a:r>
               <a:rPr lang="en-IN" sz="1600"/>
-              <a:t>first autonomous-agent experimentation on a connectome; first systematic evolved-vs-random benchmark; an open tool usable without expert knowledge.</a:t>
+              <a:t>(1) a closed-loop AI scientist that plans and interprets its own experiments — existing tools only translate single commands; (2) a multi-task benchmark with a ladder of controls (scrambled / degree- / sign- / module-preserving) to find which feature of evolved wiring matters. Simulator, virtual fly and dashboard are deliverables, not claimed as new.</a:t>
             </a:r>
             <a:endParaRPr sz="1600"/>
           </a:p>

</xml_diff>